<commit_message>
changes to ppt markup
</commit_message>
<xml_diff>
--- a/week-04/Pham_liquor_sales_presentation.pptx
+++ b/week-04/Pham_liquor_sales_presentation.pptx
@@ -6,17 +6,18 @@
   </p:sldMasterIdLst>
   <p:sldIdLst>
     <p:sldId id="256" r:id="rId2"/>
-    <p:sldId id="257" r:id="rId3"/>
-    <p:sldId id="258" r:id="rId4"/>
-    <p:sldId id="259" r:id="rId5"/>
-    <p:sldId id="260" r:id="rId6"/>
-    <p:sldId id="261" r:id="rId7"/>
-    <p:sldId id="262" r:id="rId8"/>
-    <p:sldId id="263" r:id="rId9"/>
-    <p:sldId id="264" r:id="rId10"/>
-    <p:sldId id="265" r:id="rId11"/>
-    <p:sldId id="266" r:id="rId12"/>
-    <p:sldId id="267" r:id="rId13"/>
+    <p:sldId id="268" r:id="rId3"/>
+    <p:sldId id="257" r:id="rId4"/>
+    <p:sldId id="258" r:id="rId5"/>
+    <p:sldId id="259" r:id="rId6"/>
+    <p:sldId id="260" r:id="rId7"/>
+    <p:sldId id="261" r:id="rId8"/>
+    <p:sldId id="262" r:id="rId9"/>
+    <p:sldId id="263" r:id="rId10"/>
+    <p:sldId id="264" r:id="rId11"/>
+    <p:sldId id="265" r:id="rId12"/>
+    <p:sldId id="266" r:id="rId13"/>
+    <p:sldId id="267" r:id="rId14"/>
   </p:sldIdLst>
   <p:sldSz cx="12192000" cy="6858000"/>
   <p:notesSz cx="6858000" cy="9144000"/>
@@ -3418,6 +3419,89 @@
   <p:cSld>
     <p:spTree>
       <p:nvGrpSpPr>
+        <p:cNvPr id="1" name=""/>
+        <p:cNvGrpSpPr/>
+        <p:nvPr/>
+      </p:nvGrpSpPr>
+      <p:grpSpPr>
+        <a:xfrm>
+          <a:off x="0" y="0"/>
+          <a:ext cx="0" cy="0"/>
+          <a:chOff x="0" y="0"/>
+          <a:chExt cx="0" cy="0"/>
+        </a:xfrm>
+      </p:grpSpPr>
+      <p:sp>
+        <p:nvSpPr>
+          <p:cNvPr id="2" name="Title 1">
+            <a:extLst>
+              <a:ext uri="{FF2B5EF4-FFF2-40B4-BE49-F238E27FC236}">
+                <a16:creationId xmlns:a16="http://schemas.microsoft.com/office/drawing/2014/main" id="{5A019B50-658E-240A-5EF5-18DFB48C4DB3}"/>
+              </a:ext>
+            </a:extLst>
+          </p:cNvPr>
+          <p:cNvSpPr>
+            <a:spLocks noGrp="1"/>
+          </p:cNvSpPr>
+          <p:nvPr>
+            <p:ph type="title"/>
+          </p:nvPr>
+        </p:nvSpPr>
+        <p:spPr/>
+        <p:txBody>
+          <a:bodyPr/>
+          <a:lstStyle/>
+          <a:p>
+            <a:r>
+              <a:rPr lang="en-US" dirty="0"/>
+              <a:t>Analysis 3 Opportunities 2</a:t>
+            </a:r>
+          </a:p>
+        </p:txBody>
+      </p:sp>
+      <p:sp>
+        <p:nvSpPr>
+          <p:cNvPr id="3" name="Content Placeholder 2">
+            <a:extLst>
+              <a:ext uri="{FF2B5EF4-FFF2-40B4-BE49-F238E27FC236}">
+                <a16:creationId xmlns:a16="http://schemas.microsoft.com/office/drawing/2014/main" id="{029FA1F5-5121-5C37-06A1-25AEB2125E7B}"/>
+              </a:ext>
+            </a:extLst>
+          </p:cNvPr>
+          <p:cNvSpPr>
+            <a:spLocks noGrp="1"/>
+          </p:cNvSpPr>
+          <p:nvPr>
+            <p:ph idx="1"/>
+          </p:nvPr>
+        </p:nvSpPr>
+        <p:spPr/>
+        <p:txBody>
+          <a:bodyPr/>
+          <a:lstStyle/>
+          <a:p>
+            <a:endParaRPr lang="en-US"/>
+          </a:p>
+        </p:txBody>
+      </p:sp>
+    </p:spTree>
+    <p:extLst>
+      <p:ext uri="{BB962C8B-B14F-4D97-AF65-F5344CB8AC3E}">
+        <p14:creationId xmlns:p14="http://schemas.microsoft.com/office/powerpoint/2010/main" val="1640769834"/>
+      </p:ext>
+    </p:extLst>
+  </p:cSld>
+  <p:clrMapOvr>
+    <a:masterClrMapping/>
+  </p:clrMapOvr>
+</p:sld>
+</file>
+
+<file path=ppt/slides/slide11.xml><?xml version="1.0" encoding="utf-8"?>
+<p:sld xmlns:a="http://schemas.openxmlformats.org/drawingml/2006/main" xmlns:r="http://schemas.openxmlformats.org/officeDocument/2006/relationships" xmlns:p="http://schemas.openxmlformats.org/presentationml/2006/main">
+  <p:cSld>
+    <p:spTree>
+      <p:nvGrpSpPr>
         <p:cNvPr id="1" name="">
           <a:extLst>
             <a:ext uri="{FF2B5EF4-FFF2-40B4-BE49-F238E27FC236}">
@@ -3502,7 +3586,7 @@
 </p:sld>
 </file>
 
-<file path=ppt/slides/slide11.xml><?xml version="1.0" encoding="utf-8"?>
+<file path=ppt/slides/slide12.xml><?xml version="1.0" encoding="utf-8"?>
 <p:sld xmlns:a="http://schemas.openxmlformats.org/drawingml/2006/main" xmlns:r="http://schemas.openxmlformats.org/officeDocument/2006/relationships" xmlns:p="http://schemas.openxmlformats.org/presentationml/2006/main">
   <p:cSld>
     <p:spTree>
@@ -3591,7 +3675,7 @@
 </p:sld>
 </file>
 
-<file path=ppt/slides/slide12.xml><?xml version="1.0" encoding="utf-8"?>
+<file path=ppt/slides/slide13.xml><?xml version="1.0" encoding="utf-8"?>
 <p:sld xmlns:a="http://schemas.openxmlformats.org/drawingml/2006/main" xmlns:r="http://schemas.openxmlformats.org/officeDocument/2006/relationships" xmlns:p="http://schemas.openxmlformats.org/presentationml/2006/main">
   <p:cSld>
     <p:spTree>
@@ -3702,7 +3786,7 @@
           <p:cNvPr id="2" name="Title 1">
             <a:extLst>
               <a:ext uri="{FF2B5EF4-FFF2-40B4-BE49-F238E27FC236}">
-                <a16:creationId xmlns:a16="http://schemas.microsoft.com/office/drawing/2014/main" id="{3BF32740-F662-BCD9-5E98-135BDC2BBE9F}"/>
+                <a16:creationId xmlns:a16="http://schemas.microsoft.com/office/drawing/2014/main" id="{98C590B0-CD87-8061-6E30-BFE5DF5D1947}"/>
               </a:ext>
             </a:extLst>
           </p:cNvPr>
@@ -3720,7 +3804,7 @@
           <a:p>
             <a:r>
               <a:rPr lang="en-US" dirty="0"/>
-              <a:t>Scenario</a:t>
+              <a:t>About Us</a:t>
             </a:r>
           </a:p>
         </p:txBody>
@@ -3730,7 +3814,7 @@
           <p:cNvPr id="3" name="Content Placeholder 2">
             <a:extLst>
               <a:ext uri="{FF2B5EF4-FFF2-40B4-BE49-F238E27FC236}">
-                <a16:creationId xmlns:a16="http://schemas.microsoft.com/office/drawing/2014/main" id="{DEC6ED37-AF01-E906-5F3A-EEB9B5127614}"/>
+                <a16:creationId xmlns:a16="http://schemas.microsoft.com/office/drawing/2014/main" id="{FEE45D3A-A9EC-FB84-F3F2-F395D25570D9}"/>
               </a:ext>
             </a:extLst>
           </p:cNvPr>
@@ -3753,7 +3837,7 @@
     </p:spTree>
     <p:extLst>
       <p:ext uri="{BB962C8B-B14F-4D97-AF65-F5344CB8AC3E}">
-        <p14:creationId xmlns:p14="http://schemas.microsoft.com/office/powerpoint/2010/main" val="2707976681"/>
+        <p14:creationId xmlns:p14="http://schemas.microsoft.com/office/powerpoint/2010/main" val="2354719096"/>
       </p:ext>
     </p:extLst>
   </p:cSld>
@@ -3785,6 +3869,89 @@
           <p:cNvPr id="2" name="Title 1">
             <a:extLst>
               <a:ext uri="{FF2B5EF4-FFF2-40B4-BE49-F238E27FC236}">
+                <a16:creationId xmlns:a16="http://schemas.microsoft.com/office/drawing/2014/main" id="{3BF32740-F662-BCD9-5E98-135BDC2BBE9F}"/>
+              </a:ext>
+            </a:extLst>
+          </p:cNvPr>
+          <p:cNvSpPr>
+            <a:spLocks noGrp="1"/>
+          </p:cNvSpPr>
+          <p:nvPr>
+            <p:ph type="title"/>
+          </p:nvPr>
+        </p:nvSpPr>
+        <p:spPr/>
+        <p:txBody>
+          <a:bodyPr/>
+          <a:lstStyle/>
+          <a:p>
+            <a:r>
+              <a:rPr lang="en-US" dirty="0"/>
+              <a:t>Scenario</a:t>
+            </a:r>
+          </a:p>
+        </p:txBody>
+      </p:sp>
+      <p:sp>
+        <p:nvSpPr>
+          <p:cNvPr id="3" name="Content Placeholder 2">
+            <a:extLst>
+              <a:ext uri="{FF2B5EF4-FFF2-40B4-BE49-F238E27FC236}">
+                <a16:creationId xmlns:a16="http://schemas.microsoft.com/office/drawing/2014/main" id="{DEC6ED37-AF01-E906-5F3A-EEB9B5127614}"/>
+              </a:ext>
+            </a:extLst>
+          </p:cNvPr>
+          <p:cNvSpPr>
+            <a:spLocks noGrp="1"/>
+          </p:cNvSpPr>
+          <p:nvPr>
+            <p:ph idx="1"/>
+          </p:nvPr>
+        </p:nvSpPr>
+        <p:spPr/>
+        <p:txBody>
+          <a:bodyPr/>
+          <a:lstStyle/>
+          <a:p>
+            <a:endParaRPr lang="en-US"/>
+          </a:p>
+        </p:txBody>
+      </p:sp>
+    </p:spTree>
+    <p:extLst>
+      <p:ext uri="{BB962C8B-B14F-4D97-AF65-F5344CB8AC3E}">
+        <p14:creationId xmlns:p14="http://schemas.microsoft.com/office/powerpoint/2010/main" val="2707976681"/>
+      </p:ext>
+    </p:extLst>
+  </p:cSld>
+  <p:clrMapOvr>
+    <a:masterClrMapping/>
+  </p:clrMapOvr>
+</p:sld>
+</file>
+
+<file path=ppt/slides/slide4.xml><?xml version="1.0" encoding="utf-8"?>
+<p:sld xmlns:a="http://schemas.openxmlformats.org/drawingml/2006/main" xmlns:r="http://schemas.openxmlformats.org/officeDocument/2006/relationships" xmlns:p="http://schemas.openxmlformats.org/presentationml/2006/main">
+  <p:cSld>
+    <p:spTree>
+      <p:nvGrpSpPr>
+        <p:cNvPr id="1" name=""/>
+        <p:cNvGrpSpPr/>
+        <p:nvPr/>
+      </p:nvGrpSpPr>
+      <p:grpSpPr>
+        <a:xfrm>
+          <a:off x="0" y="0"/>
+          <a:ext cx="0" cy="0"/>
+          <a:chOff x="0" y="0"/>
+          <a:chExt cx="0" cy="0"/>
+        </a:xfrm>
+      </p:grpSpPr>
+      <p:sp>
+        <p:nvSpPr>
+          <p:cNvPr id="2" name="Title 1">
+            <a:extLst>
+              <a:ext uri="{FF2B5EF4-FFF2-40B4-BE49-F238E27FC236}">
                 <a16:creationId xmlns:a16="http://schemas.microsoft.com/office/drawing/2014/main" id="{9E218537-E472-8EB1-74F4-698C93711D74}"/>
               </a:ext>
             </a:extLst>
@@ -3846,7 +4013,7 @@
 </p:sld>
 </file>
 
-<file path=ppt/slides/slide4.xml><?xml version="1.0" encoding="utf-8"?>
+<file path=ppt/slides/slide5.xml><?xml version="1.0" encoding="utf-8"?>
 <p:sld xmlns:a="http://schemas.openxmlformats.org/drawingml/2006/main" xmlns:r="http://schemas.openxmlformats.org/officeDocument/2006/relationships" xmlns:p="http://schemas.openxmlformats.org/presentationml/2006/main">
   <p:cSld>
     <p:spTree>
@@ -3935,7 +4102,7 @@
 </p:sld>
 </file>
 
-<file path=ppt/slides/slide5.xml><?xml version="1.0" encoding="utf-8"?>
+<file path=ppt/slides/slide6.xml><?xml version="1.0" encoding="utf-8"?>
 <p:sld xmlns:a="http://schemas.openxmlformats.org/drawingml/2006/main" xmlns:r="http://schemas.openxmlformats.org/officeDocument/2006/relationships" xmlns:p="http://schemas.openxmlformats.org/presentationml/2006/main">
   <p:cSld>
     <p:spTree>
@@ -4024,7 +4191,7 @@
 </p:sld>
 </file>
 
-<file path=ppt/slides/slide6.xml><?xml version="1.0" encoding="utf-8"?>
+<file path=ppt/slides/slide7.xml><?xml version="1.0" encoding="utf-8"?>
 <p:sld xmlns:a="http://schemas.openxmlformats.org/drawingml/2006/main" xmlns:r="http://schemas.openxmlformats.org/officeDocument/2006/relationships" xmlns:p="http://schemas.openxmlformats.org/presentationml/2006/main">
   <p:cSld>
     <p:spTree>
@@ -4113,7 +4280,7 @@
 </p:sld>
 </file>
 
-<file path=ppt/slides/slide7.xml><?xml version="1.0" encoding="utf-8"?>
+<file path=ppt/slides/slide8.xml><?xml version="1.0" encoding="utf-8"?>
 <p:sld xmlns:a="http://schemas.openxmlformats.org/drawingml/2006/main" xmlns:r="http://schemas.openxmlformats.org/officeDocument/2006/relationships" xmlns:p="http://schemas.openxmlformats.org/presentationml/2006/main">
   <p:cSld>
     <p:spTree>
@@ -4202,7 +4369,7 @@
 </p:sld>
 </file>
 
-<file path=ppt/slides/slide8.xml><?xml version="1.0" encoding="utf-8"?>
+<file path=ppt/slides/slide9.xml><?xml version="1.0" encoding="utf-8"?>
 <p:sld xmlns:a="http://schemas.openxmlformats.org/drawingml/2006/main" xmlns:r="http://schemas.openxmlformats.org/officeDocument/2006/relationships" xmlns:p="http://schemas.openxmlformats.org/presentationml/2006/main">
   <p:cSld>
     <p:spTree>
@@ -4282,89 +4449,6 @@
     <p:extLst>
       <p:ext uri="{BB962C8B-B14F-4D97-AF65-F5344CB8AC3E}">
         <p14:creationId xmlns:p14="http://schemas.microsoft.com/office/powerpoint/2010/main" val="3435706688"/>
-      </p:ext>
-    </p:extLst>
-  </p:cSld>
-  <p:clrMapOvr>
-    <a:masterClrMapping/>
-  </p:clrMapOvr>
-</p:sld>
-</file>
-
-<file path=ppt/slides/slide9.xml><?xml version="1.0" encoding="utf-8"?>
-<p:sld xmlns:a="http://schemas.openxmlformats.org/drawingml/2006/main" xmlns:r="http://schemas.openxmlformats.org/officeDocument/2006/relationships" xmlns:p="http://schemas.openxmlformats.org/presentationml/2006/main">
-  <p:cSld>
-    <p:spTree>
-      <p:nvGrpSpPr>
-        <p:cNvPr id="1" name=""/>
-        <p:cNvGrpSpPr/>
-        <p:nvPr/>
-      </p:nvGrpSpPr>
-      <p:grpSpPr>
-        <a:xfrm>
-          <a:off x="0" y="0"/>
-          <a:ext cx="0" cy="0"/>
-          <a:chOff x="0" y="0"/>
-          <a:chExt cx="0" cy="0"/>
-        </a:xfrm>
-      </p:grpSpPr>
-      <p:sp>
-        <p:nvSpPr>
-          <p:cNvPr id="2" name="Title 1">
-            <a:extLst>
-              <a:ext uri="{FF2B5EF4-FFF2-40B4-BE49-F238E27FC236}">
-                <a16:creationId xmlns:a16="http://schemas.microsoft.com/office/drawing/2014/main" id="{5A019B50-658E-240A-5EF5-18DFB48C4DB3}"/>
-              </a:ext>
-            </a:extLst>
-          </p:cNvPr>
-          <p:cNvSpPr>
-            <a:spLocks noGrp="1"/>
-          </p:cNvSpPr>
-          <p:nvPr>
-            <p:ph type="title"/>
-          </p:nvPr>
-        </p:nvSpPr>
-        <p:spPr/>
-        <p:txBody>
-          <a:bodyPr/>
-          <a:lstStyle/>
-          <a:p>
-            <a:r>
-              <a:rPr lang="en-US" dirty="0"/>
-              <a:t>Analysis 3 Opportunities 2</a:t>
-            </a:r>
-          </a:p>
-        </p:txBody>
-      </p:sp>
-      <p:sp>
-        <p:nvSpPr>
-          <p:cNvPr id="3" name="Content Placeholder 2">
-            <a:extLst>
-              <a:ext uri="{FF2B5EF4-FFF2-40B4-BE49-F238E27FC236}">
-                <a16:creationId xmlns:a16="http://schemas.microsoft.com/office/drawing/2014/main" id="{029FA1F5-5121-5C37-06A1-25AEB2125E7B}"/>
-              </a:ext>
-            </a:extLst>
-          </p:cNvPr>
-          <p:cNvSpPr>
-            <a:spLocks noGrp="1"/>
-          </p:cNvSpPr>
-          <p:nvPr>
-            <p:ph idx="1"/>
-          </p:nvPr>
-        </p:nvSpPr>
-        <p:spPr/>
-        <p:txBody>
-          <a:bodyPr/>
-          <a:lstStyle/>
-          <a:p>
-            <a:endParaRPr lang="en-US"/>
-          </a:p>
-        </p:txBody>
-      </p:sp>
-    </p:spTree>
-    <p:extLst>
-      <p:ext uri="{BB962C8B-B14F-4D97-AF65-F5344CB8AC3E}">
-        <p14:creationId xmlns:p14="http://schemas.microsoft.com/office/powerpoint/2010/main" val="1640769834"/>
       </p:ext>
     </p:extLst>
   </p:cSld>

</xml_diff>

<commit_message>
working query script on deriving figures for presentation; summary statistics
</commit_message>
<xml_diff>
--- a/week-04/Pham_liquor_sales_presentation.pptx
+++ b/week-04/Pham_liquor_sales_presentation.pptx
@@ -4,6 +4,9 @@
   <p:sldMasterIdLst>
     <p:sldMasterId id="2147483672" r:id="rId1"/>
   </p:sldMasterIdLst>
+  <p:notesMasterIdLst>
+    <p:notesMasterId r:id="rId15"/>
+  </p:notesMasterIdLst>
   <p:sldIdLst>
     <p:sldId id="256" r:id="rId2"/>
     <p:sldId id="268" r:id="rId3"/>
@@ -116,7 +119,466 @@
       </a:defRPr>
     </a:lvl9pPr>
   </p:defaultTextStyle>
+  <p:extLst>
+    <p:ext uri="{EFAFB233-063F-42B5-8137-9DF3F51BA10A}">
+      <p15:sldGuideLst xmlns:p15="http://schemas.microsoft.com/office/powerpoint/2012/main"/>
+    </p:ext>
+  </p:extLst>
 </p:presentation>
+</file>
+
+<file path=ppt/notesMasters/notesMaster1.xml><?xml version="1.0" encoding="utf-8"?>
+<p:notesMaster xmlns:a="http://schemas.openxmlformats.org/drawingml/2006/main" xmlns:r="http://schemas.openxmlformats.org/officeDocument/2006/relationships" xmlns:p="http://schemas.openxmlformats.org/presentationml/2006/main">
+  <p:cSld>
+    <p:bg>
+      <p:bgRef idx="1001">
+        <a:schemeClr val="bg1"/>
+      </p:bgRef>
+    </p:bg>
+    <p:spTree>
+      <p:nvGrpSpPr>
+        <p:cNvPr id="1" name=""/>
+        <p:cNvGrpSpPr/>
+        <p:nvPr/>
+      </p:nvGrpSpPr>
+      <p:grpSpPr>
+        <a:xfrm>
+          <a:off x="0" y="0"/>
+          <a:ext cx="0" cy="0"/>
+          <a:chOff x="0" y="0"/>
+          <a:chExt cx="0" cy="0"/>
+        </a:xfrm>
+      </p:grpSpPr>
+      <p:sp>
+        <p:nvSpPr>
+          <p:cNvPr id="2" name="Header Placeholder 1"/>
+          <p:cNvSpPr>
+            <a:spLocks noGrp="1"/>
+          </p:cNvSpPr>
+          <p:nvPr>
+            <p:ph type="hdr" sz="quarter"/>
+          </p:nvPr>
+        </p:nvSpPr>
+        <p:spPr>
+          <a:xfrm>
+            <a:off x="0" y="0"/>
+            <a:ext cx="2971800" cy="458788"/>
+          </a:xfrm>
+          <a:prstGeom prst="rect">
+            <a:avLst/>
+          </a:prstGeom>
+        </p:spPr>
+        <p:txBody>
+          <a:bodyPr vert="horz" lIns="91440" tIns="45720" rIns="91440" bIns="45720" rtlCol="0"/>
+          <a:lstStyle>
+            <a:lvl1pPr algn="l">
+              <a:defRPr sz="1200"/>
+            </a:lvl1pPr>
+          </a:lstStyle>
+          <a:p>
+            <a:endParaRPr lang="en-US"/>
+          </a:p>
+        </p:txBody>
+      </p:sp>
+      <p:sp>
+        <p:nvSpPr>
+          <p:cNvPr id="3" name="Date Placeholder 2"/>
+          <p:cNvSpPr>
+            <a:spLocks noGrp="1"/>
+          </p:cNvSpPr>
+          <p:nvPr>
+            <p:ph type="dt" idx="1"/>
+          </p:nvPr>
+        </p:nvSpPr>
+        <p:spPr>
+          <a:xfrm>
+            <a:off x="3884613" y="0"/>
+            <a:ext cx="2971800" cy="458788"/>
+          </a:xfrm>
+          <a:prstGeom prst="rect">
+            <a:avLst/>
+          </a:prstGeom>
+        </p:spPr>
+        <p:txBody>
+          <a:bodyPr vert="horz" lIns="91440" tIns="45720" rIns="91440" bIns="45720" rtlCol="0"/>
+          <a:lstStyle>
+            <a:lvl1pPr algn="r">
+              <a:defRPr sz="1200"/>
+            </a:lvl1pPr>
+          </a:lstStyle>
+          <a:p>
+            <a:fld id="{5B0FB398-5626-4DAA-BD19-B2F8F3D1EB3C}" type="datetimeFigureOut">
+              <a:rPr lang="en-US" smtClean="0"/>
+              <a:t>4/29/2026</a:t>
+            </a:fld>
+            <a:endParaRPr lang="en-US"/>
+          </a:p>
+        </p:txBody>
+      </p:sp>
+      <p:sp>
+        <p:nvSpPr>
+          <p:cNvPr id="4" name="Slide Image Placeholder 3"/>
+          <p:cNvSpPr>
+            <a:spLocks noGrp="1" noRot="1" noChangeAspect="1"/>
+          </p:cNvSpPr>
+          <p:nvPr>
+            <p:ph type="sldImg" idx="2"/>
+          </p:nvPr>
+        </p:nvSpPr>
+        <p:spPr>
+          <a:xfrm>
+            <a:off x="685800" y="1143000"/>
+            <a:ext cx="5486400" cy="3086100"/>
+          </a:xfrm>
+          <a:prstGeom prst="rect">
+            <a:avLst/>
+          </a:prstGeom>
+          <a:noFill/>
+          <a:ln w="12700">
+            <a:solidFill>
+              <a:prstClr val="black"/>
+            </a:solidFill>
+          </a:ln>
+        </p:spPr>
+        <p:txBody>
+          <a:bodyPr vert="horz" lIns="91440" tIns="45720" rIns="91440" bIns="45720" rtlCol="0" anchor="ctr"/>
+          <a:lstStyle/>
+          <a:p>
+            <a:endParaRPr lang="en-US"/>
+          </a:p>
+        </p:txBody>
+      </p:sp>
+      <p:sp>
+        <p:nvSpPr>
+          <p:cNvPr id="5" name="Notes Placeholder 4"/>
+          <p:cNvSpPr>
+            <a:spLocks noGrp="1"/>
+          </p:cNvSpPr>
+          <p:nvPr>
+            <p:ph type="body" sz="quarter" idx="3"/>
+          </p:nvPr>
+        </p:nvSpPr>
+        <p:spPr>
+          <a:xfrm>
+            <a:off x="685800" y="4400550"/>
+            <a:ext cx="5486400" cy="3600450"/>
+          </a:xfrm>
+          <a:prstGeom prst="rect">
+            <a:avLst/>
+          </a:prstGeom>
+        </p:spPr>
+        <p:txBody>
+          <a:bodyPr vert="horz" lIns="91440" tIns="45720" rIns="91440" bIns="45720" rtlCol="0"/>
+          <a:lstStyle/>
+          <a:p>
+            <a:pPr lvl="0"/>
+            <a:r>
+              <a:rPr lang="en-US"/>
+              <a:t>Click to edit Master text styles</a:t>
+            </a:r>
+          </a:p>
+          <a:p>
+            <a:pPr lvl="1"/>
+            <a:r>
+              <a:rPr lang="en-US"/>
+              <a:t>Second level</a:t>
+            </a:r>
+          </a:p>
+          <a:p>
+            <a:pPr lvl="2"/>
+            <a:r>
+              <a:rPr lang="en-US"/>
+              <a:t>Third level</a:t>
+            </a:r>
+          </a:p>
+          <a:p>
+            <a:pPr lvl="3"/>
+            <a:r>
+              <a:rPr lang="en-US"/>
+              <a:t>Fourth level</a:t>
+            </a:r>
+          </a:p>
+          <a:p>
+            <a:pPr lvl="4"/>
+            <a:r>
+              <a:rPr lang="en-US"/>
+              <a:t>Fifth level</a:t>
+            </a:r>
+          </a:p>
+        </p:txBody>
+      </p:sp>
+      <p:sp>
+        <p:nvSpPr>
+          <p:cNvPr id="6" name="Footer Placeholder 5"/>
+          <p:cNvSpPr>
+            <a:spLocks noGrp="1"/>
+          </p:cNvSpPr>
+          <p:nvPr>
+            <p:ph type="ftr" sz="quarter" idx="4"/>
+          </p:nvPr>
+        </p:nvSpPr>
+        <p:spPr>
+          <a:xfrm>
+            <a:off x="0" y="8685213"/>
+            <a:ext cx="2971800" cy="458787"/>
+          </a:xfrm>
+          <a:prstGeom prst="rect">
+            <a:avLst/>
+          </a:prstGeom>
+        </p:spPr>
+        <p:txBody>
+          <a:bodyPr vert="horz" lIns="91440" tIns="45720" rIns="91440" bIns="45720" rtlCol="0" anchor="b"/>
+          <a:lstStyle>
+            <a:lvl1pPr algn="l">
+              <a:defRPr sz="1200"/>
+            </a:lvl1pPr>
+          </a:lstStyle>
+          <a:p>
+            <a:endParaRPr lang="en-US"/>
+          </a:p>
+        </p:txBody>
+      </p:sp>
+      <p:sp>
+        <p:nvSpPr>
+          <p:cNvPr id="7" name="Slide Number Placeholder 6"/>
+          <p:cNvSpPr>
+            <a:spLocks noGrp="1"/>
+          </p:cNvSpPr>
+          <p:nvPr>
+            <p:ph type="sldNum" sz="quarter" idx="5"/>
+          </p:nvPr>
+        </p:nvSpPr>
+        <p:spPr>
+          <a:xfrm>
+            <a:off x="3884613" y="8685213"/>
+            <a:ext cx="2971800" cy="458787"/>
+          </a:xfrm>
+          <a:prstGeom prst="rect">
+            <a:avLst/>
+          </a:prstGeom>
+        </p:spPr>
+        <p:txBody>
+          <a:bodyPr vert="horz" lIns="91440" tIns="45720" rIns="91440" bIns="45720" rtlCol="0" anchor="b"/>
+          <a:lstStyle>
+            <a:lvl1pPr algn="r">
+              <a:defRPr sz="1200"/>
+            </a:lvl1pPr>
+          </a:lstStyle>
+          <a:p>
+            <a:fld id="{9A18230D-6974-4A26-8365-62E356C4785F}" type="slidenum">
+              <a:rPr lang="en-US" smtClean="0"/>
+              <a:t>‹#›</a:t>
+            </a:fld>
+            <a:endParaRPr lang="en-US"/>
+          </a:p>
+        </p:txBody>
+      </p:sp>
+    </p:spTree>
+    <p:extLst>
+      <p:ext uri="{BB962C8B-B14F-4D97-AF65-F5344CB8AC3E}">
+        <p14:creationId xmlns:p14="http://schemas.microsoft.com/office/powerpoint/2010/main" val="1036821984"/>
+      </p:ext>
+    </p:extLst>
+  </p:cSld>
+  <p:clrMap bg1="lt1" tx1="dk1" bg2="lt2" tx2="dk2" accent1="accent1" accent2="accent2" accent3="accent3" accent4="accent4" accent5="accent5" accent6="accent6" hlink="hlink" folHlink="folHlink"/>
+  <p:notesStyle>
+    <a:lvl1pPr marL="0" algn="l" defTabSz="914400" rtl="0" eaLnBrk="1" latinLnBrk="0" hangingPunct="1">
+      <a:defRPr sz="1200" kern="1200">
+        <a:solidFill>
+          <a:schemeClr val="tx1"/>
+        </a:solidFill>
+        <a:latin typeface="+mn-lt"/>
+        <a:ea typeface="+mn-ea"/>
+        <a:cs typeface="+mn-cs"/>
+      </a:defRPr>
+    </a:lvl1pPr>
+    <a:lvl2pPr marL="457200" algn="l" defTabSz="914400" rtl="0" eaLnBrk="1" latinLnBrk="0" hangingPunct="1">
+      <a:defRPr sz="1200" kern="1200">
+        <a:solidFill>
+          <a:schemeClr val="tx1"/>
+        </a:solidFill>
+        <a:latin typeface="+mn-lt"/>
+        <a:ea typeface="+mn-ea"/>
+        <a:cs typeface="+mn-cs"/>
+      </a:defRPr>
+    </a:lvl2pPr>
+    <a:lvl3pPr marL="914400" algn="l" defTabSz="914400" rtl="0" eaLnBrk="1" latinLnBrk="0" hangingPunct="1">
+      <a:defRPr sz="1200" kern="1200">
+        <a:solidFill>
+          <a:schemeClr val="tx1"/>
+        </a:solidFill>
+        <a:latin typeface="+mn-lt"/>
+        <a:ea typeface="+mn-ea"/>
+        <a:cs typeface="+mn-cs"/>
+      </a:defRPr>
+    </a:lvl3pPr>
+    <a:lvl4pPr marL="1371600" algn="l" defTabSz="914400" rtl="0" eaLnBrk="1" latinLnBrk="0" hangingPunct="1">
+      <a:defRPr sz="1200" kern="1200">
+        <a:solidFill>
+          <a:schemeClr val="tx1"/>
+        </a:solidFill>
+        <a:latin typeface="+mn-lt"/>
+        <a:ea typeface="+mn-ea"/>
+        <a:cs typeface="+mn-cs"/>
+      </a:defRPr>
+    </a:lvl4pPr>
+    <a:lvl5pPr marL="1828800" algn="l" defTabSz="914400" rtl="0" eaLnBrk="1" latinLnBrk="0" hangingPunct="1">
+      <a:defRPr sz="1200" kern="1200">
+        <a:solidFill>
+          <a:schemeClr val="tx1"/>
+        </a:solidFill>
+        <a:latin typeface="+mn-lt"/>
+        <a:ea typeface="+mn-ea"/>
+        <a:cs typeface="+mn-cs"/>
+      </a:defRPr>
+    </a:lvl5pPr>
+    <a:lvl6pPr marL="2286000" algn="l" defTabSz="914400" rtl="0" eaLnBrk="1" latinLnBrk="0" hangingPunct="1">
+      <a:defRPr sz="1200" kern="1200">
+        <a:solidFill>
+          <a:schemeClr val="tx1"/>
+        </a:solidFill>
+        <a:latin typeface="+mn-lt"/>
+        <a:ea typeface="+mn-ea"/>
+        <a:cs typeface="+mn-cs"/>
+      </a:defRPr>
+    </a:lvl6pPr>
+    <a:lvl7pPr marL="2743200" algn="l" defTabSz="914400" rtl="0" eaLnBrk="1" latinLnBrk="0" hangingPunct="1">
+      <a:defRPr sz="1200" kern="1200">
+        <a:solidFill>
+          <a:schemeClr val="tx1"/>
+        </a:solidFill>
+        <a:latin typeface="+mn-lt"/>
+        <a:ea typeface="+mn-ea"/>
+        <a:cs typeface="+mn-cs"/>
+      </a:defRPr>
+    </a:lvl7pPr>
+    <a:lvl8pPr marL="3200400" algn="l" defTabSz="914400" rtl="0" eaLnBrk="1" latinLnBrk="0" hangingPunct="1">
+      <a:defRPr sz="1200" kern="1200">
+        <a:solidFill>
+          <a:schemeClr val="tx1"/>
+        </a:solidFill>
+        <a:latin typeface="+mn-lt"/>
+        <a:ea typeface="+mn-ea"/>
+        <a:cs typeface="+mn-cs"/>
+      </a:defRPr>
+    </a:lvl8pPr>
+    <a:lvl9pPr marL="3657600" algn="l" defTabSz="914400" rtl="0" eaLnBrk="1" latinLnBrk="0" hangingPunct="1">
+      <a:defRPr sz="1200" kern="1200">
+        <a:solidFill>
+          <a:schemeClr val="tx1"/>
+        </a:solidFill>
+        <a:latin typeface="+mn-lt"/>
+        <a:ea typeface="+mn-ea"/>
+        <a:cs typeface="+mn-cs"/>
+      </a:defRPr>
+    </a:lvl9pPr>
+  </p:notesStyle>
+</p:notesMaster>
+</file>
+
+<file path=ppt/notesSlides/notesSlide1.xml><?xml version="1.0" encoding="utf-8"?>
+<p:notes xmlns:a="http://schemas.openxmlformats.org/drawingml/2006/main" xmlns:r="http://schemas.openxmlformats.org/officeDocument/2006/relationships" xmlns:p="http://schemas.openxmlformats.org/presentationml/2006/main">
+  <p:cSld>
+    <p:spTree>
+      <p:nvGrpSpPr>
+        <p:cNvPr id="1" name=""/>
+        <p:cNvGrpSpPr/>
+        <p:nvPr/>
+      </p:nvGrpSpPr>
+      <p:grpSpPr>
+        <a:xfrm>
+          <a:off x="0" y="0"/>
+          <a:ext cx="0" cy="0"/>
+          <a:chOff x="0" y="0"/>
+          <a:chExt cx="0" cy="0"/>
+        </a:xfrm>
+      </p:grpSpPr>
+      <p:sp>
+        <p:nvSpPr>
+          <p:cNvPr id="2" name="Slide Image Placeholder 1"/>
+          <p:cNvSpPr>
+            <a:spLocks noGrp="1" noRot="1" noChangeAspect="1"/>
+          </p:cNvSpPr>
+          <p:nvPr>
+            <p:ph type="sldImg"/>
+          </p:nvPr>
+        </p:nvSpPr>
+        <p:spPr/>
+      </p:sp>
+      <p:sp>
+        <p:nvSpPr>
+          <p:cNvPr id="3" name="Notes Placeholder 2"/>
+          <p:cNvSpPr>
+            <a:spLocks noGrp="1"/>
+          </p:cNvSpPr>
+          <p:nvPr>
+            <p:ph type="body" idx="1"/>
+          </p:nvPr>
+        </p:nvSpPr>
+        <p:spPr/>
+        <p:txBody>
+          <a:bodyPr/>
+          <a:lstStyle/>
+          <a:p>
+            <a:r>
+              <a:rPr lang="en-US" dirty="0"/>
+              <a:t>You have been brought on as a data consultant by Constellation Brands to analyze sales performance using the Iowa Liquor Sales database, with a specific focus on transactions from 2014. The company wants to better understand how one of its product categories or brands performed during that year across different markets to inform future strategy.</a:t>
+            </a:r>
+          </a:p>
+          <a:p>
+            <a:r>
+              <a:rPr lang="en-US" dirty="0"/>
+              <a:t>Your role is to conduct a SWOT-style analysis by writing SQL queries that explore transaction data, product performance, store activity, and regional trends. You will focus on a specific category or vendor within the dataset to identify strengths, weaknesses, opportunities, and threats based on 2014 sales data.</a:t>
+            </a:r>
+          </a:p>
+          <a:p>
+            <a:r>
+              <a:rPr lang="en-US" dirty="0"/>
+              <a:t>As part of your analysis, you will generate insights from the data and export selected results to create visualizations that support your findings. These insights will be used to present actionable recommendations to Constellation Brands’ leadership team.</a:t>
+            </a:r>
+          </a:p>
+          <a:p>
+            <a:r>
+              <a:rPr lang="en-US" dirty="0"/>
+              <a:t>(OpenAI 2026)</a:t>
+            </a:r>
+          </a:p>
+        </p:txBody>
+      </p:sp>
+      <p:sp>
+        <p:nvSpPr>
+          <p:cNvPr id="4" name="Slide Number Placeholder 3"/>
+          <p:cNvSpPr>
+            <a:spLocks noGrp="1"/>
+          </p:cNvSpPr>
+          <p:nvPr>
+            <p:ph type="sldNum" sz="quarter" idx="5"/>
+          </p:nvPr>
+        </p:nvSpPr>
+        <p:spPr/>
+        <p:txBody>
+          <a:bodyPr/>
+          <a:lstStyle/>
+          <a:p>
+            <a:fld id="{9A18230D-6974-4A26-8365-62E356C4785F}" type="slidenum">
+              <a:rPr lang="en-US" smtClean="0"/>
+              <a:t>3</a:t>
+            </a:fld>
+            <a:endParaRPr lang="en-US"/>
+          </a:p>
+        </p:txBody>
+      </p:sp>
+    </p:spTree>
+    <p:extLst>
+      <p:ext uri="{BB962C8B-B14F-4D97-AF65-F5344CB8AC3E}">
+        <p14:creationId xmlns:p14="http://schemas.microsoft.com/office/powerpoint/2010/main" val="3156598360"/>
+      </p:ext>
+    </p:extLst>
+  </p:cSld>
+  <p:clrMapOvr>
+    <a:masterClrMapping/>
+  </p:clrMapOvr>
+</p:notes>
 </file>
 
 <file path=ppt/slideLayouts/slideLayout1.xml><?xml version="1.0" encoding="utf-8"?>
@@ -3830,7 +4292,29 @@
           <a:bodyPr/>
           <a:lstStyle/>
           <a:p>
-            <a:endParaRPr lang="en-US"/>
+            <a:r>
+              <a:rPr lang="en-US" dirty="0"/>
+              <a:t>Leading international producer and marketer of beer, wine, and spirits</a:t>
+            </a:r>
+          </a:p>
+          <a:p>
+            <a:pPr lvl="1"/>
+            <a:r>
+              <a:rPr lang="en-US" dirty="0"/>
+              <a:t>Markets in U.S, Mexico, Nea Zealand, and Italy</a:t>
+            </a:r>
+          </a:p>
+          <a:p>
+            <a:r>
+              <a:rPr lang="en-US" u="sng" dirty="0"/>
+              <a:t>Worth Reaching For</a:t>
+            </a:r>
+          </a:p>
+          <a:p>
+            <a:r>
+              <a:rPr lang="en-US" dirty="0"/>
+              <a:t>s</a:t>
+            </a:r>
           </a:p>
         </p:txBody>
       </p:sp>
@@ -3913,7 +4397,13 @@
           <a:bodyPr/>
           <a:lstStyle/>
           <a:p>
-            <a:endParaRPr lang="en-US"/>
+            <a:pPr marL="0" indent="0">
+              <a:buNone/>
+            </a:pPr>
+            <a:r>
+              <a:rPr lang="en-US" dirty="0"/>
+              <a:t>You have been brought on as a data consultant by Constellation Brands to analyze sales performance using the Iowa Liquor Sales database The company wants to better understand how it performed during that year across different markets to inform future strategy.</a:t>
+            </a:r>
           </a:p>
         </p:txBody>
       </p:sp>
@@ -3996,7 +4486,13 @@
           <a:bodyPr/>
           <a:lstStyle/>
           <a:p>
-            <a:endParaRPr lang="en-US"/>
+            <a:r>
+              <a:rPr lang="en-US"/>
+              <a:t>Time Period (2014-01-01 to 2014-12-31)</a:t>
+            </a:r>
+          </a:p>
+          <a:p>
+            <a:endParaRPr lang="en-US" dirty="0"/>
           </a:p>
         </p:txBody>
       </p:sp>
@@ -4771,4 +5267,319 @@
     </a:ext>
   </a:extLst>
 </a:theme>
+</file>
+
+<file path=ppt/theme/theme2.xml><?xml version="1.0" encoding="utf-8"?>
+<a:theme xmlns:a="http://schemas.openxmlformats.org/drawingml/2006/main" name="Office Theme">
+  <a:themeElements>
+    <a:clrScheme name="Office">
+      <a:dk1>
+        <a:sysClr val="windowText" lastClr="000000"/>
+      </a:dk1>
+      <a:lt1>
+        <a:sysClr val="window" lastClr="FFFFFF"/>
+      </a:lt1>
+      <a:dk2>
+        <a:srgbClr val="0E2841"/>
+      </a:dk2>
+      <a:lt2>
+        <a:srgbClr val="E8E8E8"/>
+      </a:lt2>
+      <a:accent1>
+        <a:srgbClr val="156082"/>
+      </a:accent1>
+      <a:accent2>
+        <a:srgbClr val="E97132"/>
+      </a:accent2>
+      <a:accent3>
+        <a:srgbClr val="196B24"/>
+      </a:accent3>
+      <a:accent4>
+        <a:srgbClr val="0F9ED5"/>
+      </a:accent4>
+      <a:accent5>
+        <a:srgbClr val="A02B93"/>
+      </a:accent5>
+      <a:accent6>
+        <a:srgbClr val="4EA72E"/>
+      </a:accent6>
+      <a:hlink>
+        <a:srgbClr val="467886"/>
+      </a:hlink>
+      <a:folHlink>
+        <a:srgbClr val="96607D"/>
+      </a:folHlink>
+    </a:clrScheme>
+    <a:fontScheme name="Office">
+      <a:majorFont>
+        <a:latin typeface="Aptos Display" panose="02110004020202020204"/>
+        <a:ea typeface=""/>
+        <a:cs typeface=""/>
+        <a:font script="Jpan" typeface="游ゴシック Light"/>
+        <a:font script="Hang" typeface="맑은 고딕"/>
+        <a:font script="Hans" typeface="等线 Light"/>
+        <a:font script="Hant" typeface="新細明體"/>
+        <a:font script="Arab" typeface="Times New Roman"/>
+        <a:font script="Hebr" typeface="Times New Roman"/>
+        <a:font script="Thai" typeface="Angsana New"/>
+        <a:font script="Ethi" typeface="Nyala"/>
+        <a:font script="Beng" typeface="Vrinda"/>
+        <a:font script="Gujr" typeface="Shruti"/>
+        <a:font script="Khmr" typeface="MoolBoran"/>
+        <a:font script="Knda" typeface="Tunga"/>
+        <a:font script="Guru" typeface="Raavi"/>
+        <a:font script="Cans" typeface="Euphemia"/>
+        <a:font script="Cher" typeface="Plantagenet Cherokee"/>
+        <a:font script="Yiii" typeface="Microsoft Yi Baiti"/>
+        <a:font script="Tibt" typeface="Microsoft Himalaya"/>
+        <a:font script="Thaa" typeface="MV Boli"/>
+        <a:font script="Deva" typeface="Mangal"/>
+        <a:font script="Telu" typeface="Gautami"/>
+        <a:font script="Taml" typeface="Latha"/>
+        <a:font script="Syrc" typeface="Estrangelo Edessa"/>
+        <a:font script="Orya" typeface="Kalinga"/>
+        <a:font script="Mlym" typeface="Kartika"/>
+        <a:font script="Laoo" typeface="DokChampa"/>
+        <a:font script="Sinh" typeface="Iskoola Pota"/>
+        <a:font script="Mong" typeface="Mongolian Baiti"/>
+        <a:font script="Viet" typeface="Times New Roman"/>
+        <a:font script="Uigh" typeface="Microsoft Uighur"/>
+        <a:font script="Geor" typeface="Sylfaen"/>
+        <a:font script="Armn" typeface="Arial"/>
+        <a:font script="Bugi" typeface="Leelawadee UI"/>
+        <a:font script="Bopo" typeface="Microsoft JhengHei"/>
+        <a:font script="Java" typeface="Javanese Text"/>
+        <a:font script="Lisu" typeface="Segoe UI"/>
+        <a:font script="Mymr" typeface="Myanmar Text"/>
+        <a:font script="Nkoo" typeface="Ebrima"/>
+        <a:font script="Olck" typeface="Nirmala UI"/>
+        <a:font script="Osma" typeface="Ebrima"/>
+        <a:font script="Phag" typeface="Phagspa"/>
+        <a:font script="Syrn" typeface="Estrangelo Edessa"/>
+        <a:font script="Syrj" typeface="Estrangelo Edessa"/>
+        <a:font script="Syre" typeface="Estrangelo Edessa"/>
+        <a:font script="Sora" typeface="Nirmala UI"/>
+        <a:font script="Tale" typeface="Microsoft Tai Le"/>
+        <a:font script="Talu" typeface="Microsoft New Tai Lue"/>
+        <a:font script="Tfng" typeface="Ebrima"/>
+      </a:majorFont>
+      <a:minorFont>
+        <a:latin typeface="Aptos" panose="02110004020202020204"/>
+        <a:ea typeface=""/>
+        <a:cs typeface=""/>
+        <a:font script="Jpan" typeface="游ゴシック"/>
+        <a:font script="Hang" typeface="맑은 고딕"/>
+        <a:font script="Hans" typeface="等线"/>
+        <a:font script="Hant" typeface="新細明體"/>
+        <a:font script="Arab" typeface="Arial"/>
+        <a:font script="Hebr" typeface="Arial"/>
+        <a:font script="Thai" typeface="Cordia New"/>
+        <a:font script="Ethi" typeface="Nyala"/>
+        <a:font script="Beng" typeface="Vrinda"/>
+        <a:font script="Gujr" typeface="Shruti"/>
+        <a:font script="Khmr" typeface="DaunPenh"/>
+        <a:font script="Knda" typeface="Tunga"/>
+        <a:font script="Guru" typeface="Raavi"/>
+        <a:font script="Cans" typeface="Euphemia"/>
+        <a:font script="Cher" typeface="Plantagenet Cherokee"/>
+        <a:font script="Yiii" typeface="Microsoft Yi Baiti"/>
+        <a:font script="Tibt" typeface="Microsoft Himalaya"/>
+        <a:font script="Thaa" typeface="MV Boli"/>
+        <a:font script="Deva" typeface="Mangal"/>
+        <a:font script="Telu" typeface="Gautami"/>
+        <a:font script="Taml" typeface="Latha"/>
+        <a:font script="Syrc" typeface="Estrangelo Edessa"/>
+        <a:font script="Orya" typeface="Kalinga"/>
+        <a:font script="Mlym" typeface="Kartika"/>
+        <a:font script="Laoo" typeface="DokChampa"/>
+        <a:font script="Sinh" typeface="Iskoola Pota"/>
+        <a:font script="Mong" typeface="Mongolian Baiti"/>
+        <a:font script="Viet" typeface="Arial"/>
+        <a:font script="Uigh" typeface="Microsoft Uighur"/>
+        <a:font script="Geor" typeface="Sylfaen"/>
+        <a:font script="Armn" typeface="Arial"/>
+        <a:font script="Bugi" typeface="Leelawadee UI"/>
+        <a:font script="Bopo" typeface="Microsoft JhengHei"/>
+        <a:font script="Java" typeface="Javanese Text"/>
+        <a:font script="Lisu" typeface="Segoe UI"/>
+        <a:font script="Mymr" typeface="Myanmar Text"/>
+        <a:font script="Nkoo" typeface="Ebrima"/>
+        <a:font script="Olck" typeface="Nirmala UI"/>
+        <a:font script="Osma" typeface="Ebrima"/>
+        <a:font script="Phag" typeface="Phagspa"/>
+        <a:font script="Syrn" typeface="Estrangelo Edessa"/>
+        <a:font script="Syrj" typeface="Estrangelo Edessa"/>
+        <a:font script="Syre" typeface="Estrangelo Edessa"/>
+        <a:font script="Sora" typeface="Nirmala UI"/>
+        <a:font script="Tale" typeface="Microsoft Tai Le"/>
+        <a:font script="Talu" typeface="Microsoft New Tai Lue"/>
+        <a:font script="Tfng" typeface="Ebrima"/>
+      </a:minorFont>
+    </a:fontScheme>
+    <a:fmtScheme name="Office">
+      <a:fillStyleLst>
+        <a:solidFill>
+          <a:schemeClr val="phClr"/>
+        </a:solidFill>
+        <a:gradFill rotWithShape="1">
+          <a:gsLst>
+            <a:gs pos="0">
+              <a:schemeClr val="phClr">
+                <a:lumMod val="110000"/>
+                <a:satMod val="105000"/>
+                <a:tint val="67000"/>
+              </a:schemeClr>
+            </a:gs>
+            <a:gs pos="50000">
+              <a:schemeClr val="phClr">
+                <a:lumMod val="105000"/>
+                <a:satMod val="103000"/>
+                <a:tint val="73000"/>
+              </a:schemeClr>
+            </a:gs>
+            <a:gs pos="100000">
+              <a:schemeClr val="phClr">
+                <a:lumMod val="105000"/>
+                <a:satMod val="109000"/>
+                <a:tint val="81000"/>
+              </a:schemeClr>
+            </a:gs>
+          </a:gsLst>
+          <a:lin ang="5400000" scaled="0"/>
+        </a:gradFill>
+        <a:gradFill rotWithShape="1">
+          <a:gsLst>
+            <a:gs pos="0">
+              <a:schemeClr val="phClr">
+                <a:satMod val="103000"/>
+                <a:lumMod val="102000"/>
+                <a:tint val="94000"/>
+              </a:schemeClr>
+            </a:gs>
+            <a:gs pos="50000">
+              <a:schemeClr val="phClr">
+                <a:satMod val="110000"/>
+                <a:lumMod val="100000"/>
+                <a:shade val="100000"/>
+              </a:schemeClr>
+            </a:gs>
+            <a:gs pos="100000">
+              <a:schemeClr val="phClr">
+                <a:lumMod val="99000"/>
+                <a:satMod val="120000"/>
+                <a:shade val="78000"/>
+              </a:schemeClr>
+            </a:gs>
+          </a:gsLst>
+          <a:lin ang="5400000" scaled="0"/>
+        </a:gradFill>
+      </a:fillStyleLst>
+      <a:lnStyleLst>
+        <a:ln w="12700" cap="flat" cmpd="sng" algn="ctr">
+          <a:solidFill>
+            <a:schemeClr val="phClr"/>
+          </a:solidFill>
+          <a:prstDash val="solid"/>
+          <a:miter lim="800000"/>
+        </a:ln>
+        <a:ln w="19050" cap="flat" cmpd="sng" algn="ctr">
+          <a:solidFill>
+            <a:schemeClr val="phClr"/>
+          </a:solidFill>
+          <a:prstDash val="solid"/>
+          <a:miter lim="800000"/>
+        </a:ln>
+        <a:ln w="25400" cap="flat" cmpd="sng" algn="ctr">
+          <a:solidFill>
+            <a:schemeClr val="phClr"/>
+          </a:solidFill>
+          <a:prstDash val="solid"/>
+          <a:miter lim="800000"/>
+        </a:ln>
+      </a:lnStyleLst>
+      <a:effectStyleLst>
+        <a:effectStyle>
+          <a:effectLst/>
+        </a:effectStyle>
+        <a:effectStyle>
+          <a:effectLst/>
+        </a:effectStyle>
+        <a:effectStyle>
+          <a:effectLst>
+            <a:outerShdw blurRad="57150" dist="19050" dir="5400000" algn="ctr" rotWithShape="0">
+              <a:srgbClr val="000000">
+                <a:alpha val="63000"/>
+              </a:srgbClr>
+            </a:outerShdw>
+          </a:effectLst>
+        </a:effectStyle>
+      </a:effectStyleLst>
+      <a:bgFillStyleLst>
+        <a:solidFill>
+          <a:schemeClr val="phClr"/>
+        </a:solidFill>
+        <a:solidFill>
+          <a:schemeClr val="phClr">
+            <a:tint val="95000"/>
+            <a:satMod val="170000"/>
+          </a:schemeClr>
+        </a:solidFill>
+        <a:gradFill rotWithShape="1">
+          <a:gsLst>
+            <a:gs pos="0">
+              <a:schemeClr val="phClr">
+                <a:tint val="93000"/>
+                <a:satMod val="150000"/>
+                <a:shade val="98000"/>
+                <a:lumMod val="102000"/>
+              </a:schemeClr>
+            </a:gs>
+            <a:gs pos="50000">
+              <a:schemeClr val="phClr">
+                <a:tint val="98000"/>
+                <a:satMod val="130000"/>
+                <a:shade val="90000"/>
+                <a:lumMod val="103000"/>
+              </a:schemeClr>
+            </a:gs>
+            <a:gs pos="100000">
+              <a:schemeClr val="phClr">
+                <a:shade val="63000"/>
+                <a:satMod val="120000"/>
+              </a:schemeClr>
+            </a:gs>
+          </a:gsLst>
+          <a:lin ang="5400000" scaled="0"/>
+        </a:gradFill>
+      </a:bgFillStyleLst>
+    </a:fmtScheme>
+  </a:themeElements>
+  <a:objectDefaults>
+    <a:lnDef>
+      <a:spPr/>
+      <a:bodyPr/>
+      <a:lstStyle/>
+      <a:style>
+        <a:lnRef idx="2">
+          <a:schemeClr val="accent1"/>
+        </a:lnRef>
+        <a:fillRef idx="0">
+          <a:schemeClr val="accent1"/>
+        </a:fillRef>
+        <a:effectRef idx="1">
+          <a:schemeClr val="accent1"/>
+        </a:effectRef>
+        <a:fontRef idx="minor">
+          <a:schemeClr val="tx1"/>
+        </a:fontRef>
+      </a:style>
+    </a:lnDef>
+  </a:objectDefaults>
+  <a:extraClrSchemeLst/>
+  <a:extLst>
+    <a:ext uri="{05A4C25C-085E-4340-85A3-A5531E510DB2}">
+      <thm15:themeFamily xmlns:thm15="http://schemas.microsoft.com/office/thememl/2012/main" name="Office Theme" id="{2E142A2C-CD16-42D6-873A-C26D2A0506FA}" vid="{1BDDFF52-6CD6-40A5-AB3C-68EB2F1E4D0A}"/>
+    </a:ext>
+  </a:extLst>
+</a:theme>
 </file>
</xml_diff>

<commit_message>
minor changes to slides
</commit_message>
<xml_diff>
--- a/week-04/Pham_liquor_sales_presentation.pptx
+++ b/week-04/Pham_liquor_sales_presentation.pptx
@@ -209,7 +209,7 @@
           <a:p>
             <a:fld id="{5B0FB398-5626-4DAA-BD19-B2F8F3D1EB3C}" type="datetimeFigureOut">
               <a:rPr lang="en-US" smtClean="0"/>
-              <a:t>4/29/2026</a:t>
+              <a:t>4/30/2026</a:t>
             </a:fld>
             <a:endParaRPr lang="en-US"/>
           </a:p>
@@ -581,6 +581,300 @@
 </p:notes>
 </file>
 
+<file path=ppt/notesSlides/notesSlide2.xml><?xml version="1.0" encoding="utf-8"?>
+<p:notes xmlns:a="http://schemas.openxmlformats.org/drawingml/2006/main" xmlns:r="http://schemas.openxmlformats.org/officeDocument/2006/relationships" xmlns:p="http://schemas.openxmlformats.org/presentationml/2006/main">
+  <p:cSld>
+    <p:spTree>
+      <p:nvGrpSpPr>
+        <p:cNvPr id="1" name=""/>
+        <p:cNvGrpSpPr/>
+        <p:nvPr/>
+      </p:nvGrpSpPr>
+      <p:grpSpPr>
+        <a:xfrm>
+          <a:off x="0" y="0"/>
+          <a:ext cx="0" cy="0"/>
+          <a:chOff x="0" y="0"/>
+          <a:chExt cx="0" cy="0"/>
+        </a:xfrm>
+      </p:grpSpPr>
+      <p:sp>
+        <p:nvSpPr>
+          <p:cNvPr id="2" name="Slide Image Placeholder 1"/>
+          <p:cNvSpPr>
+            <a:spLocks noGrp="1" noRot="1" noChangeAspect="1"/>
+          </p:cNvSpPr>
+          <p:nvPr>
+            <p:ph type="sldImg"/>
+          </p:nvPr>
+        </p:nvSpPr>
+        <p:spPr/>
+      </p:sp>
+      <p:sp>
+        <p:nvSpPr>
+          <p:cNvPr id="3" name="Notes Placeholder 2"/>
+          <p:cNvSpPr>
+            <a:spLocks noGrp="1"/>
+          </p:cNvSpPr>
+          <p:nvPr>
+            <p:ph type="body" idx="1"/>
+          </p:nvPr>
+        </p:nvSpPr>
+        <p:spPr/>
+        <p:txBody>
+          <a:bodyPr/>
+          <a:lstStyle/>
+          <a:p>
+            <a:r>
+              <a:rPr lang="en-US" dirty="0"/>
+              <a:t>Notes:</a:t>
+            </a:r>
+          </a:p>
+          <a:p>
+            <a:r>
+              <a:rPr lang="en-US" dirty="0"/>
+              <a:t>Year 2014</a:t>
+            </a:r>
+          </a:p>
+          <a:p>
+            <a:endParaRPr lang="en-US" dirty="0"/>
+          </a:p>
+        </p:txBody>
+      </p:sp>
+      <p:sp>
+        <p:nvSpPr>
+          <p:cNvPr id="4" name="Slide Number Placeholder 3"/>
+          <p:cNvSpPr>
+            <a:spLocks noGrp="1"/>
+          </p:cNvSpPr>
+          <p:nvPr>
+            <p:ph type="sldNum" sz="quarter" idx="5"/>
+          </p:nvPr>
+        </p:nvSpPr>
+        <p:spPr/>
+        <p:txBody>
+          <a:bodyPr/>
+          <a:lstStyle/>
+          <a:p>
+            <a:fld id="{9A18230D-6974-4A26-8365-62E356C4785F}" type="slidenum">
+              <a:rPr lang="en-US" smtClean="0"/>
+              <a:t>4</a:t>
+            </a:fld>
+            <a:endParaRPr lang="en-US"/>
+          </a:p>
+        </p:txBody>
+      </p:sp>
+    </p:spTree>
+    <p:extLst>
+      <p:ext uri="{BB962C8B-B14F-4D97-AF65-F5344CB8AC3E}">
+        <p14:creationId xmlns:p14="http://schemas.microsoft.com/office/powerpoint/2010/main" val="1028827278"/>
+      </p:ext>
+    </p:extLst>
+  </p:cSld>
+  <p:clrMapOvr>
+    <a:masterClrMapping/>
+  </p:clrMapOvr>
+</p:notes>
+</file>
+
+<file path=ppt/notesSlides/notesSlide3.xml><?xml version="1.0" encoding="utf-8"?>
+<p:notes xmlns:a="http://schemas.openxmlformats.org/drawingml/2006/main" xmlns:r="http://schemas.openxmlformats.org/officeDocument/2006/relationships" xmlns:p="http://schemas.openxmlformats.org/presentationml/2006/main">
+  <p:cSld>
+    <p:spTree>
+      <p:nvGrpSpPr>
+        <p:cNvPr id="1" name=""/>
+        <p:cNvGrpSpPr/>
+        <p:nvPr/>
+      </p:nvGrpSpPr>
+      <p:grpSpPr>
+        <a:xfrm>
+          <a:off x="0" y="0"/>
+          <a:ext cx="0" cy="0"/>
+          <a:chOff x="0" y="0"/>
+          <a:chExt cx="0" cy="0"/>
+        </a:xfrm>
+      </p:grpSpPr>
+      <p:sp>
+        <p:nvSpPr>
+          <p:cNvPr id="2" name="Slide Image Placeholder 1"/>
+          <p:cNvSpPr>
+            <a:spLocks noGrp="1" noRot="1" noChangeAspect="1"/>
+          </p:cNvSpPr>
+          <p:nvPr>
+            <p:ph type="sldImg"/>
+          </p:nvPr>
+        </p:nvSpPr>
+        <p:spPr/>
+      </p:sp>
+      <p:sp>
+        <p:nvSpPr>
+          <p:cNvPr id="3" name="Notes Placeholder 2"/>
+          <p:cNvSpPr>
+            <a:spLocks noGrp="1"/>
+          </p:cNvSpPr>
+          <p:nvPr>
+            <p:ph type="body" idx="1"/>
+          </p:nvPr>
+        </p:nvSpPr>
+        <p:spPr/>
+        <p:txBody>
+          <a:bodyPr/>
+          <a:lstStyle/>
+          <a:p>
+            <a:r>
+              <a:rPr lang="en-US" dirty="0"/>
+              <a:t>How many products</a:t>
+            </a:r>
+          </a:p>
+          <a:p>
+            <a:r>
+              <a:rPr lang="en-US" dirty="0"/>
+              <a:t>Strongest Product</a:t>
+            </a:r>
+          </a:p>
+          <a:p>
+            <a:r>
+              <a:rPr lang="en-US" dirty="0"/>
+              <a:t>How does the strongest product do in its own category</a:t>
+            </a:r>
+          </a:p>
+          <a:p>
+            <a:r>
+              <a:rPr lang="en-US" dirty="0"/>
+              <a:t>	Market share</a:t>
+            </a:r>
+          </a:p>
+        </p:txBody>
+      </p:sp>
+      <p:sp>
+        <p:nvSpPr>
+          <p:cNvPr id="4" name="Slide Number Placeholder 3"/>
+          <p:cNvSpPr>
+            <a:spLocks noGrp="1"/>
+          </p:cNvSpPr>
+          <p:nvPr>
+            <p:ph type="sldNum" sz="quarter" idx="5"/>
+          </p:nvPr>
+        </p:nvSpPr>
+        <p:spPr/>
+        <p:txBody>
+          <a:bodyPr/>
+          <a:lstStyle/>
+          <a:p>
+            <a:fld id="{9A18230D-6974-4A26-8365-62E356C4785F}" type="slidenum">
+              <a:rPr lang="en-US" smtClean="0"/>
+              <a:t>5</a:t>
+            </a:fld>
+            <a:endParaRPr lang="en-US"/>
+          </a:p>
+        </p:txBody>
+      </p:sp>
+    </p:spTree>
+    <p:extLst>
+      <p:ext uri="{BB962C8B-B14F-4D97-AF65-F5344CB8AC3E}">
+        <p14:creationId xmlns:p14="http://schemas.microsoft.com/office/powerpoint/2010/main" val="2007414624"/>
+      </p:ext>
+    </p:extLst>
+  </p:cSld>
+  <p:clrMapOvr>
+    <a:masterClrMapping/>
+  </p:clrMapOvr>
+</p:notes>
+</file>
+
+<file path=ppt/notesSlides/notesSlide4.xml><?xml version="1.0" encoding="utf-8"?>
+<p:notes xmlns:a="http://schemas.openxmlformats.org/drawingml/2006/main" xmlns:r="http://schemas.openxmlformats.org/officeDocument/2006/relationships" xmlns:p="http://schemas.openxmlformats.org/presentationml/2006/main">
+  <p:cSld>
+    <p:spTree>
+      <p:nvGrpSpPr>
+        <p:cNvPr id="1" name=""/>
+        <p:cNvGrpSpPr/>
+        <p:nvPr/>
+      </p:nvGrpSpPr>
+      <p:grpSpPr>
+        <a:xfrm>
+          <a:off x="0" y="0"/>
+          <a:ext cx="0" cy="0"/>
+          <a:chOff x="0" y="0"/>
+          <a:chExt cx="0" cy="0"/>
+        </a:xfrm>
+      </p:grpSpPr>
+      <p:sp>
+        <p:nvSpPr>
+          <p:cNvPr id="2" name="Slide Image Placeholder 1"/>
+          <p:cNvSpPr>
+            <a:spLocks noGrp="1" noRot="1" noChangeAspect="1"/>
+          </p:cNvSpPr>
+          <p:nvPr>
+            <p:ph type="sldImg"/>
+          </p:nvPr>
+        </p:nvSpPr>
+        <p:spPr/>
+      </p:sp>
+      <p:sp>
+        <p:nvSpPr>
+          <p:cNvPr id="3" name="Notes Placeholder 2"/>
+          <p:cNvSpPr>
+            <a:spLocks noGrp="1"/>
+          </p:cNvSpPr>
+          <p:nvPr>
+            <p:ph type="body" idx="1"/>
+          </p:nvPr>
+        </p:nvSpPr>
+        <p:spPr/>
+        <p:txBody>
+          <a:bodyPr/>
+          <a:lstStyle/>
+          <a:p>
+            <a:r>
+              <a:rPr lang="en-US" dirty="0"/>
+              <a:t>Explore the Beer market and Wine market to see improvement</a:t>
+            </a:r>
+          </a:p>
+          <a:p>
+            <a:r>
+              <a:rPr lang="en-US" dirty="0"/>
+              <a:t>	Acquisition of Modelo to enter the beer market in 2013</a:t>
+            </a:r>
+          </a:p>
+        </p:txBody>
+      </p:sp>
+      <p:sp>
+        <p:nvSpPr>
+          <p:cNvPr id="4" name="Slide Number Placeholder 3"/>
+          <p:cNvSpPr>
+            <a:spLocks noGrp="1"/>
+          </p:cNvSpPr>
+          <p:nvPr>
+            <p:ph type="sldNum" sz="quarter" idx="5"/>
+          </p:nvPr>
+        </p:nvSpPr>
+        <p:spPr/>
+        <p:txBody>
+          <a:bodyPr/>
+          <a:lstStyle/>
+          <a:p>
+            <a:fld id="{9A18230D-6974-4A26-8365-62E356C4785F}" type="slidenum">
+              <a:rPr lang="en-US" smtClean="0"/>
+              <a:t>13</a:t>
+            </a:fld>
+            <a:endParaRPr lang="en-US"/>
+          </a:p>
+        </p:txBody>
+      </p:sp>
+    </p:spTree>
+    <p:extLst>
+      <p:ext uri="{BB962C8B-B14F-4D97-AF65-F5344CB8AC3E}">
+        <p14:creationId xmlns:p14="http://schemas.microsoft.com/office/powerpoint/2010/main" val="2836736160"/>
+      </p:ext>
+    </p:extLst>
+  </p:cSld>
+  <p:clrMapOvr>
+    <a:masterClrMapping/>
+  </p:clrMapOvr>
+</p:notes>
+</file>
+
 <file path=ppt/slideLayouts/slideLayout1.xml><?xml version="1.0" encoding="utf-8"?>
 <p:sldLayout xmlns:a="http://schemas.openxmlformats.org/drawingml/2006/main" xmlns:r="http://schemas.openxmlformats.org/officeDocument/2006/relationships" xmlns:p="http://schemas.openxmlformats.org/presentationml/2006/main" type="title" preserve="1">
   <p:cSld name="Title Slide">
@@ -728,7 +1022,7 @@
           <a:p>
             <a:fld id="{1C7CE9BF-C1FF-4E9B-97E6-64DC9D713536}" type="datetimeFigureOut">
               <a:rPr lang="en-US" smtClean="0"/>
-              <a:t>4/29/2026</a:t>
+              <a:t>4/30/2026</a:t>
             </a:fld>
             <a:endParaRPr lang="en-US"/>
           </a:p>
@@ -926,7 +1220,7 @@
           <a:p>
             <a:fld id="{1C7CE9BF-C1FF-4E9B-97E6-64DC9D713536}" type="datetimeFigureOut">
               <a:rPr lang="en-US" smtClean="0"/>
-              <a:t>4/29/2026</a:t>
+              <a:t>4/30/2026</a:t>
             </a:fld>
             <a:endParaRPr lang="en-US"/>
           </a:p>
@@ -1134,7 +1428,7 @@
           <a:p>
             <a:fld id="{1C7CE9BF-C1FF-4E9B-97E6-64DC9D713536}" type="datetimeFigureOut">
               <a:rPr lang="en-US" smtClean="0"/>
-              <a:t>4/29/2026</a:t>
+              <a:t>4/30/2026</a:t>
             </a:fld>
             <a:endParaRPr lang="en-US"/>
           </a:p>
@@ -1332,7 +1626,7 @@
           <a:p>
             <a:fld id="{1C7CE9BF-C1FF-4E9B-97E6-64DC9D713536}" type="datetimeFigureOut">
               <a:rPr lang="en-US" smtClean="0"/>
-              <a:t>4/29/2026</a:t>
+              <a:t>4/30/2026</a:t>
             </a:fld>
             <a:endParaRPr lang="en-US"/>
           </a:p>
@@ -1607,7 +1901,7 @@
           <a:p>
             <a:fld id="{1C7CE9BF-C1FF-4E9B-97E6-64DC9D713536}" type="datetimeFigureOut">
               <a:rPr lang="en-US" smtClean="0"/>
-              <a:t>4/29/2026</a:t>
+              <a:t>4/30/2026</a:t>
             </a:fld>
             <a:endParaRPr lang="en-US"/>
           </a:p>
@@ -1872,7 +2166,7 @@
           <a:p>
             <a:fld id="{1C7CE9BF-C1FF-4E9B-97E6-64DC9D713536}" type="datetimeFigureOut">
               <a:rPr lang="en-US" smtClean="0"/>
-              <a:t>4/29/2026</a:t>
+              <a:t>4/30/2026</a:t>
             </a:fld>
             <a:endParaRPr lang="en-US"/>
           </a:p>
@@ -2284,7 +2578,7 @@
           <a:p>
             <a:fld id="{1C7CE9BF-C1FF-4E9B-97E6-64DC9D713536}" type="datetimeFigureOut">
               <a:rPr lang="en-US" smtClean="0"/>
-              <a:t>4/29/2026</a:t>
+              <a:t>4/30/2026</a:t>
             </a:fld>
             <a:endParaRPr lang="en-US"/>
           </a:p>
@@ -2425,7 +2719,7 @@
           <a:p>
             <a:fld id="{1C7CE9BF-C1FF-4E9B-97E6-64DC9D713536}" type="datetimeFigureOut">
               <a:rPr lang="en-US" smtClean="0"/>
-              <a:t>4/29/2026</a:t>
+              <a:t>4/30/2026</a:t>
             </a:fld>
             <a:endParaRPr lang="en-US"/>
           </a:p>
@@ -2538,7 +2832,7 @@
           <a:p>
             <a:fld id="{1C7CE9BF-C1FF-4E9B-97E6-64DC9D713536}" type="datetimeFigureOut">
               <a:rPr lang="en-US" smtClean="0"/>
-              <a:t>4/29/2026</a:t>
+              <a:t>4/30/2026</a:t>
             </a:fld>
             <a:endParaRPr lang="en-US"/>
           </a:p>
@@ -2849,7 +3143,7 @@
           <a:p>
             <a:fld id="{1C7CE9BF-C1FF-4E9B-97E6-64DC9D713536}" type="datetimeFigureOut">
               <a:rPr lang="en-US" smtClean="0"/>
-              <a:t>4/29/2026</a:t>
+              <a:t>4/30/2026</a:t>
             </a:fld>
             <a:endParaRPr lang="en-US"/>
           </a:p>
@@ -3137,7 +3431,7 @@
           <a:p>
             <a:fld id="{1C7CE9BF-C1FF-4E9B-97E6-64DC9D713536}" type="datetimeFigureOut">
               <a:rPr lang="en-US" smtClean="0"/>
-              <a:t>4/29/2026</a:t>
+              <a:t>4/30/2026</a:t>
             </a:fld>
             <a:endParaRPr lang="en-US"/>
           </a:p>
@@ -3378,7 +3672,7 @@
           <a:p>
             <a:fld id="{1C7CE9BF-C1FF-4E9B-97E6-64DC9D713536}" type="datetimeFigureOut">
               <a:rPr lang="en-US" smtClean="0"/>
-              <a:t>4/29/2026</a:t>
+              <a:t>4/30/2026</a:t>
             </a:fld>
             <a:endParaRPr lang="en-US"/>
           </a:p>
@@ -3852,7 +4146,7 @@
           <a:p>
             <a:r>
               <a:rPr lang="en-US" dirty="0"/>
-              <a:t>Iowa Liquor Sales Analysis</a:t>
+              <a:t>2014 Iowa Liquor Sales Analysis</a:t>
             </a:r>
           </a:p>
           <a:p>

</xml_diff>